<commit_message>
Chapter 07 - Creating and Managing Layers
</commit_message>
<xml_diff>
--- a/AutoCAD .NET Developer Bootcamp (C#)/AutoCAD .NET Developer Bootcamp (C#).pptx
+++ b/AutoCAD .NET Developer Bootcamp (C#)/AutoCAD .NET Developer Bootcamp (C#).pptx
@@ -9,17 +9,18 @@
     <p:sldId id="258" r:id="rId3"/>
     <p:sldId id="259" r:id="rId4"/>
     <p:sldId id="260" r:id="rId5"/>
-    <p:sldId id="261" r:id="rId6"/>
-    <p:sldId id="262" r:id="rId7"/>
-    <p:sldId id="263" r:id="rId8"/>
-    <p:sldId id="264" r:id="rId9"/>
-    <p:sldId id="265" r:id="rId10"/>
-    <p:sldId id="266" r:id="rId11"/>
-    <p:sldId id="267" r:id="rId12"/>
-    <p:sldId id="268" r:id="rId13"/>
-    <p:sldId id="269" r:id="rId14"/>
-    <p:sldId id="270" r:id="rId15"/>
-    <p:sldId id="271" r:id="rId16"/>
+    <p:sldId id="272" r:id="rId6"/>
+    <p:sldId id="261" r:id="rId7"/>
+    <p:sldId id="262" r:id="rId8"/>
+    <p:sldId id="263" r:id="rId9"/>
+    <p:sldId id="264" r:id="rId10"/>
+    <p:sldId id="265" r:id="rId11"/>
+    <p:sldId id="266" r:id="rId12"/>
+    <p:sldId id="267" r:id="rId13"/>
+    <p:sldId id="268" r:id="rId14"/>
+    <p:sldId id="269" r:id="rId15"/>
+    <p:sldId id="270" r:id="rId16"/>
+    <p:sldId id="271" r:id="rId17"/>
   </p:sldIdLst>
   <p:sldSz cx="12192000" cy="6858000"/>
   <p:notesSz cx="6858000" cy="9144000"/>
@@ -118,6 +119,11 @@
       </a:defRPr>
     </a:lvl9pPr>
   </p:defaultTextStyle>
+  <p:extLst>
+    <p:ext uri="{EFAFB233-063F-42B5-8137-9DF3F51BA10A}">
+      <p15:sldGuideLst xmlns:p15="http://schemas.microsoft.com/office/powerpoint/2012/main"/>
+    </p:ext>
+  </p:extLst>
 </p:presentation>
 </file>
 
@@ -270,7 +276,7 @@
           <a:p>
             <a:fld id="{754FE6E7-9E02-4B4B-BF4E-4E832380C92C}" type="datetimeFigureOut">
               <a:rPr lang="en-IN" smtClean="0"/>
-              <a:t>16-09-2026</a:t>
+              <a:t>18-09-2026</a:t>
             </a:fld>
             <a:endParaRPr lang="en-IN"/>
           </a:p>
@@ -470,7 +476,7 @@
           <a:p>
             <a:fld id="{754FE6E7-9E02-4B4B-BF4E-4E832380C92C}" type="datetimeFigureOut">
               <a:rPr lang="en-IN" smtClean="0"/>
-              <a:t>16-09-2026</a:t>
+              <a:t>18-09-2026</a:t>
             </a:fld>
             <a:endParaRPr lang="en-IN"/>
           </a:p>
@@ -680,7 +686,7 @@
           <a:p>
             <a:fld id="{754FE6E7-9E02-4B4B-BF4E-4E832380C92C}" type="datetimeFigureOut">
               <a:rPr lang="en-IN" smtClean="0"/>
-              <a:t>16-09-2026</a:t>
+              <a:t>18-09-2026</a:t>
             </a:fld>
             <a:endParaRPr lang="en-IN"/>
           </a:p>
@@ -880,7 +886,7 @@
           <a:p>
             <a:fld id="{754FE6E7-9E02-4B4B-BF4E-4E832380C92C}" type="datetimeFigureOut">
               <a:rPr lang="en-IN" smtClean="0"/>
-              <a:t>16-09-2026</a:t>
+              <a:t>18-09-2026</a:t>
             </a:fld>
             <a:endParaRPr lang="en-IN"/>
           </a:p>
@@ -1156,7 +1162,7 @@
           <a:p>
             <a:fld id="{754FE6E7-9E02-4B4B-BF4E-4E832380C92C}" type="datetimeFigureOut">
               <a:rPr lang="en-IN" smtClean="0"/>
-              <a:t>16-09-2026</a:t>
+              <a:t>18-09-2026</a:t>
             </a:fld>
             <a:endParaRPr lang="en-IN"/>
           </a:p>
@@ -1424,7 +1430,7 @@
           <a:p>
             <a:fld id="{754FE6E7-9E02-4B4B-BF4E-4E832380C92C}" type="datetimeFigureOut">
               <a:rPr lang="en-IN" smtClean="0"/>
-              <a:t>16-09-2026</a:t>
+              <a:t>18-09-2026</a:t>
             </a:fld>
             <a:endParaRPr lang="en-IN"/>
           </a:p>
@@ -1839,7 +1845,7 @@
           <a:p>
             <a:fld id="{754FE6E7-9E02-4B4B-BF4E-4E832380C92C}" type="datetimeFigureOut">
               <a:rPr lang="en-IN" smtClean="0"/>
-              <a:t>16-09-2026</a:t>
+              <a:t>18-09-2026</a:t>
             </a:fld>
             <a:endParaRPr lang="en-IN"/>
           </a:p>
@@ -1981,7 +1987,7 @@
           <a:p>
             <a:fld id="{754FE6E7-9E02-4B4B-BF4E-4E832380C92C}" type="datetimeFigureOut">
               <a:rPr lang="en-IN" smtClean="0"/>
-              <a:t>16-09-2026</a:t>
+              <a:t>18-09-2026</a:t>
             </a:fld>
             <a:endParaRPr lang="en-IN"/>
           </a:p>
@@ -2094,7 +2100,7 @@
           <a:p>
             <a:fld id="{754FE6E7-9E02-4B4B-BF4E-4E832380C92C}" type="datetimeFigureOut">
               <a:rPr lang="en-IN" smtClean="0"/>
-              <a:t>16-09-2026</a:t>
+              <a:t>18-09-2026</a:t>
             </a:fld>
             <a:endParaRPr lang="en-IN"/>
           </a:p>
@@ -2407,7 +2413,7 @@
           <a:p>
             <a:fld id="{754FE6E7-9E02-4B4B-BF4E-4E832380C92C}" type="datetimeFigureOut">
               <a:rPr lang="en-IN" smtClean="0"/>
-              <a:t>16-09-2026</a:t>
+              <a:t>18-09-2026</a:t>
             </a:fld>
             <a:endParaRPr lang="en-IN"/>
           </a:p>
@@ -2696,7 +2702,7 @@
           <a:p>
             <a:fld id="{754FE6E7-9E02-4B4B-BF4E-4E832380C92C}" type="datetimeFigureOut">
               <a:rPr lang="en-IN" smtClean="0"/>
-              <a:t>16-09-2026</a:t>
+              <a:t>18-09-2026</a:t>
             </a:fld>
             <a:endParaRPr lang="en-IN"/>
           </a:p>
@@ -2939,7 +2945,7 @@
           <a:p>
             <a:fld id="{754FE6E7-9E02-4B4B-BF4E-4E832380C92C}" type="datetimeFigureOut">
               <a:rPr lang="en-IN" smtClean="0"/>
-              <a:t>16-09-2026</a:t>
+              <a:t>18-09-2026</a:t>
             </a:fld>
             <a:endParaRPr lang="en-IN"/>
           </a:p>
@@ -3454,6 +3460,213 @@
         <p:cNvPr id="1" name="">
           <a:extLst>
             <a:ext uri="{FF2B5EF4-FFF2-40B4-BE49-F238E27FC236}">
+              <a16:creationId xmlns:a16="http://schemas.microsoft.com/office/drawing/2014/main" id="{6ADD35A9-8484-397D-6E7E-B5FEC50ED72F}"/>
+            </a:ext>
+          </a:extLst>
+        </p:cNvPr>
+        <p:cNvGrpSpPr/>
+        <p:nvPr/>
+      </p:nvGrpSpPr>
+      <p:grpSpPr>
+        <a:xfrm>
+          <a:off x="0" y="0"/>
+          <a:ext cx="0" cy="0"/>
+          <a:chOff x="0" y="0"/>
+          <a:chExt cx="0" cy="0"/>
+        </a:xfrm>
+      </p:grpSpPr>
+      <p:sp>
+        <p:nvSpPr>
+          <p:cNvPr id="2" name="Title 1">
+            <a:extLst>
+              <a:ext uri="{FF2B5EF4-FFF2-40B4-BE49-F238E27FC236}">
+                <a16:creationId xmlns:a16="http://schemas.microsoft.com/office/drawing/2014/main" id="{D7129BDA-D26A-B38D-776D-FDDF033B3E43}"/>
+              </a:ext>
+            </a:extLst>
+          </p:cNvPr>
+          <p:cNvSpPr>
+            <a:spLocks noGrp="1"/>
+          </p:cNvSpPr>
+          <p:nvPr>
+            <p:ph type="title"/>
+          </p:nvPr>
+        </p:nvSpPr>
+        <p:spPr/>
+        <p:txBody>
+          <a:bodyPr>
+            <a:normAutofit/>
+          </a:bodyPr>
+          <a:lstStyle/>
+          <a:p>
+            <a:r>
+              <a:rPr lang="en-IN" dirty="0"/>
+              <a:t>Chapter 9</a:t>
+            </a:r>
+            <a:br>
+              <a:rPr lang="en-IN" dirty="0"/>
+            </a:br>
+            <a:r>
+              <a:rPr lang="en-IN" dirty="0"/>
+              <a:t>Working with Polylines</a:t>
+            </a:r>
+          </a:p>
+        </p:txBody>
+      </p:sp>
+      <p:sp>
+        <p:nvSpPr>
+          <p:cNvPr id="3" name="Text Placeholder 2">
+            <a:extLst>
+              <a:ext uri="{FF2B5EF4-FFF2-40B4-BE49-F238E27FC236}">
+                <a16:creationId xmlns:a16="http://schemas.microsoft.com/office/drawing/2014/main" id="{855F551E-0F5F-1964-97E2-D658EA3D8D65}"/>
+              </a:ext>
+            </a:extLst>
+          </p:cNvPr>
+          <p:cNvSpPr>
+            <a:spLocks noGrp="1"/>
+          </p:cNvSpPr>
+          <p:nvPr>
+            <p:ph type="body" idx="1"/>
+          </p:nvPr>
+        </p:nvSpPr>
+        <p:spPr/>
+        <p:txBody>
+          <a:bodyPr/>
+          <a:lstStyle/>
+          <a:p>
+            <a:r>
+              <a:rPr lang="en-IN" b="0" dirty="0"/>
+              <a:t>Topics</a:t>
+            </a:r>
+          </a:p>
+        </p:txBody>
+      </p:sp>
+      <p:sp>
+        <p:nvSpPr>
+          <p:cNvPr id="4" name="Content Placeholder 3">
+            <a:extLst>
+              <a:ext uri="{FF2B5EF4-FFF2-40B4-BE49-F238E27FC236}">
+                <a16:creationId xmlns:a16="http://schemas.microsoft.com/office/drawing/2014/main" id="{C8E9BBB0-178C-BAFD-96F7-49D545C2684C}"/>
+              </a:ext>
+            </a:extLst>
+          </p:cNvPr>
+          <p:cNvSpPr>
+            <a:spLocks noGrp="1"/>
+          </p:cNvSpPr>
+          <p:nvPr>
+            <p:ph sz="half" idx="2"/>
+          </p:nvPr>
+        </p:nvSpPr>
+        <p:spPr/>
+        <p:txBody>
+          <a:bodyPr>
+            <a:normAutofit/>
+          </a:bodyPr>
+          <a:lstStyle/>
+          <a:p>
+            <a:r>
+              <a:rPr lang="en-IN" dirty="0"/>
+              <a:t>Polyline</a:t>
+            </a:r>
+          </a:p>
+          <a:p>
+            <a:r>
+              <a:rPr lang="en-IN" dirty="0"/>
+              <a:t>Vertex Management</a:t>
+            </a:r>
+          </a:p>
+          <a:p>
+            <a:r>
+              <a:rPr lang="en-IN" dirty="0"/>
+              <a:t>Closed Shapes</a:t>
+            </a:r>
+          </a:p>
+          <a:p>
+            <a:r>
+              <a:rPr lang="en-IN" dirty="0"/>
+              <a:t>Mini Project - Generate floor layouts.</a:t>
+            </a:r>
+          </a:p>
+        </p:txBody>
+      </p:sp>
+      <p:sp>
+        <p:nvSpPr>
+          <p:cNvPr id="5" name="Text Placeholder 4">
+            <a:extLst>
+              <a:ext uri="{FF2B5EF4-FFF2-40B4-BE49-F238E27FC236}">
+                <a16:creationId xmlns:a16="http://schemas.microsoft.com/office/drawing/2014/main" id="{3F1FE253-2395-591D-CA2B-414001105EFF}"/>
+              </a:ext>
+            </a:extLst>
+          </p:cNvPr>
+          <p:cNvSpPr>
+            <a:spLocks noGrp="1"/>
+          </p:cNvSpPr>
+          <p:nvPr>
+            <p:ph type="body" sz="quarter" idx="3"/>
+          </p:nvPr>
+        </p:nvSpPr>
+        <p:spPr/>
+        <p:txBody>
+          <a:bodyPr/>
+          <a:lstStyle/>
+          <a:p>
+            <a:r>
+              <a:rPr lang="en-IN" b="0" dirty="0"/>
+              <a:t>Outcome</a:t>
+            </a:r>
+          </a:p>
+        </p:txBody>
+      </p:sp>
+      <p:sp>
+        <p:nvSpPr>
+          <p:cNvPr id="6" name="Content Placeholder 5">
+            <a:extLst>
+              <a:ext uri="{FF2B5EF4-FFF2-40B4-BE49-F238E27FC236}">
+                <a16:creationId xmlns:a16="http://schemas.microsoft.com/office/drawing/2014/main" id="{8967E232-99D9-BA37-1119-72E34A7E87C8}"/>
+              </a:ext>
+            </a:extLst>
+          </p:cNvPr>
+          <p:cNvSpPr>
+            <a:spLocks noGrp="1"/>
+          </p:cNvSpPr>
+          <p:nvPr>
+            <p:ph sz="quarter" idx="4"/>
+          </p:nvPr>
+        </p:nvSpPr>
+        <p:spPr/>
+        <p:txBody>
+          <a:bodyPr>
+            <a:normAutofit/>
+          </a:bodyPr>
+          <a:lstStyle/>
+          <a:p>
+            <a:r>
+              <a:rPr lang="en-IN" dirty="0"/>
+              <a:t>Complex geometry creation.</a:t>
+            </a:r>
+          </a:p>
+        </p:txBody>
+      </p:sp>
+    </p:spTree>
+    <p:extLst>
+      <p:ext uri="{BB962C8B-B14F-4D97-AF65-F5344CB8AC3E}">
+        <p14:creationId xmlns:p14="http://schemas.microsoft.com/office/powerpoint/2010/main" val="1726483327"/>
+      </p:ext>
+    </p:extLst>
+  </p:cSld>
+  <p:clrMapOvr>
+    <a:masterClrMapping/>
+  </p:clrMapOvr>
+</p:sld>
+</file>
+
+<file path=ppt/slides/slide11.xml><?xml version="1.0" encoding="utf-8"?>
+<p:sld xmlns:a="http://schemas.openxmlformats.org/drawingml/2006/main" xmlns:r="http://schemas.openxmlformats.org/officeDocument/2006/relationships" xmlns:p="http://schemas.openxmlformats.org/presentationml/2006/main">
+  <p:cSld>
+    <p:spTree>
+      <p:nvGrpSpPr>
+        <p:cNvPr id="1" name="">
+          <a:extLst>
+            <a:ext uri="{FF2B5EF4-FFF2-40B4-BE49-F238E27FC236}">
               <a16:creationId xmlns:a16="http://schemas.microsoft.com/office/drawing/2014/main" id="{73B46642-06F5-6D34-2248-0C1F7EE95980}"/>
             </a:ext>
           </a:extLst>
@@ -3653,7 +3866,7 @@
 </p:sld>
 </file>
 
-<file path=ppt/slides/slide11.xml><?xml version="1.0" encoding="utf-8"?>
+<file path=ppt/slides/slide12.xml><?xml version="1.0" encoding="utf-8"?>
 <p:sld xmlns:a="http://schemas.openxmlformats.org/drawingml/2006/main" xmlns:r="http://schemas.openxmlformats.org/officeDocument/2006/relationships" xmlns:p="http://schemas.openxmlformats.org/presentationml/2006/main">
   <p:cSld>
     <p:spTree>
@@ -3860,7 +4073,7 @@
 </p:sld>
 </file>
 
-<file path=ppt/slides/slide12.xml><?xml version="1.0" encoding="utf-8"?>
+<file path=ppt/slides/slide13.xml><?xml version="1.0" encoding="utf-8"?>
 <p:sld xmlns:a="http://schemas.openxmlformats.org/drawingml/2006/main" xmlns:r="http://schemas.openxmlformats.org/officeDocument/2006/relationships" xmlns:p="http://schemas.openxmlformats.org/presentationml/2006/main">
   <p:cSld>
     <p:spTree>
@@ -4069,7 +4282,7 @@
 </p:sld>
 </file>
 
-<file path=ppt/slides/slide13.xml><?xml version="1.0" encoding="utf-8"?>
+<file path=ppt/slides/slide14.xml><?xml version="1.0" encoding="utf-8"?>
 <p:sld xmlns:a="http://schemas.openxmlformats.org/drawingml/2006/main" xmlns:r="http://schemas.openxmlformats.org/officeDocument/2006/relationships" xmlns:p="http://schemas.openxmlformats.org/presentationml/2006/main">
   <p:cSld>
     <p:spTree>
@@ -4282,7 +4495,7 @@
 </p:sld>
 </file>
 
-<file path=ppt/slides/slide14.xml><?xml version="1.0" encoding="utf-8"?>
+<file path=ppt/slides/slide15.xml><?xml version="1.0" encoding="utf-8"?>
 <p:sld xmlns:a="http://schemas.openxmlformats.org/drawingml/2006/main" xmlns:r="http://schemas.openxmlformats.org/officeDocument/2006/relationships" xmlns:p="http://schemas.openxmlformats.org/presentationml/2006/main">
   <p:cSld>
     <p:spTree>
@@ -4505,7 +4718,7 @@
 </p:sld>
 </file>
 
-<file path=ppt/slides/slide15.xml><?xml version="1.0" encoding="utf-8"?>
+<file path=ppt/slides/slide16.xml><?xml version="1.0" encoding="utf-8"?>
 <p:sld xmlns:a="http://schemas.openxmlformats.org/drawingml/2006/main" xmlns:r="http://schemas.openxmlformats.org/officeDocument/2006/relationships" xmlns:p="http://schemas.openxmlformats.org/presentationml/2006/main">
   <p:cSld>
     <p:spTree>
@@ -5378,6 +5591,246 @@
         <p:cNvPr id="1" name="">
           <a:extLst>
             <a:ext uri="{FF2B5EF4-FFF2-40B4-BE49-F238E27FC236}">
+              <a16:creationId xmlns:a16="http://schemas.microsoft.com/office/drawing/2014/main" id="{0064C1AE-98F9-4830-90A2-544CC6549104}"/>
+            </a:ext>
+          </a:extLst>
+        </p:cNvPr>
+        <p:cNvGrpSpPr/>
+        <p:nvPr/>
+      </p:nvGrpSpPr>
+      <p:grpSpPr>
+        <a:xfrm>
+          <a:off x="0" y="0"/>
+          <a:ext cx="0" cy="0"/>
+          <a:chOff x="0" y="0"/>
+          <a:chExt cx="0" cy="0"/>
+        </a:xfrm>
+      </p:grpSpPr>
+      <p:sp>
+        <p:nvSpPr>
+          <p:cNvPr id="2" name="Title 1">
+            <a:extLst>
+              <a:ext uri="{FF2B5EF4-FFF2-40B4-BE49-F238E27FC236}">
+                <a16:creationId xmlns:a16="http://schemas.microsoft.com/office/drawing/2014/main" id="{D0D62C23-CDE4-4FC8-73F4-3055F8561FDD}"/>
+              </a:ext>
+            </a:extLst>
+          </p:cNvPr>
+          <p:cNvSpPr>
+            <a:spLocks noGrp="1"/>
+          </p:cNvSpPr>
+          <p:nvPr>
+            <p:ph type="title"/>
+          </p:nvPr>
+        </p:nvSpPr>
+        <p:spPr/>
+        <p:txBody>
+          <a:bodyPr>
+            <a:normAutofit/>
+          </a:bodyPr>
+          <a:lstStyle/>
+          <a:p>
+            <a:r>
+              <a:rPr lang="en-IN" dirty="0"/>
+              <a:t>Chapter 4</a:t>
+            </a:r>
+            <a:br>
+              <a:rPr lang="en-IN" dirty="0"/>
+            </a:br>
+            <a:r>
+              <a:rPr lang="en-IN" dirty="0"/>
+              <a:t>Understanding AutoCAD Architecture</a:t>
+            </a:r>
+          </a:p>
+        </p:txBody>
+      </p:sp>
+      <p:sp>
+        <p:nvSpPr>
+          <p:cNvPr id="3" name="Text Placeholder 2">
+            <a:extLst>
+              <a:ext uri="{FF2B5EF4-FFF2-40B4-BE49-F238E27FC236}">
+                <a16:creationId xmlns:a16="http://schemas.microsoft.com/office/drawing/2014/main" id="{8AF5AC7D-02C8-E492-B3B8-FFBAD2ED8A43}"/>
+              </a:ext>
+            </a:extLst>
+          </p:cNvPr>
+          <p:cNvSpPr>
+            <a:spLocks noGrp="1"/>
+          </p:cNvSpPr>
+          <p:nvPr>
+            <p:ph type="body" idx="1"/>
+          </p:nvPr>
+        </p:nvSpPr>
+        <p:spPr/>
+        <p:txBody>
+          <a:bodyPr/>
+          <a:lstStyle/>
+          <a:p>
+            <a:r>
+              <a:rPr lang="en-IN" b="0" dirty="0"/>
+              <a:t>Topics</a:t>
+            </a:r>
+          </a:p>
+        </p:txBody>
+      </p:sp>
+      <p:sp>
+        <p:nvSpPr>
+          <p:cNvPr id="4" name="Content Placeholder 3">
+            <a:extLst>
+              <a:ext uri="{FF2B5EF4-FFF2-40B4-BE49-F238E27FC236}">
+                <a16:creationId xmlns:a16="http://schemas.microsoft.com/office/drawing/2014/main" id="{75DBEAD1-11DB-6246-12C5-0CF9F881ADB2}"/>
+              </a:ext>
+            </a:extLst>
+          </p:cNvPr>
+          <p:cNvSpPr>
+            <a:spLocks noGrp="1"/>
+          </p:cNvSpPr>
+          <p:nvPr>
+            <p:ph sz="half" idx="2"/>
+          </p:nvPr>
+        </p:nvSpPr>
+        <p:spPr/>
+        <p:txBody>
+          <a:bodyPr>
+            <a:normAutofit fontScale="85000" lnSpcReduction="20000"/>
+          </a:bodyPr>
+          <a:lstStyle/>
+          <a:p>
+            <a:r>
+              <a:rPr lang="en-GB" dirty="0"/>
+              <a:t>Application</a:t>
+            </a:r>
+          </a:p>
+          <a:p>
+            <a:pPr marL="0" indent="0">
+              <a:buNone/>
+            </a:pPr>
+            <a:r>
+              <a:rPr lang="en-GB" dirty="0"/>
+              <a:t>   └ Document</a:t>
+            </a:r>
+          </a:p>
+          <a:p>
+            <a:pPr marL="0" indent="0">
+              <a:buNone/>
+            </a:pPr>
+            <a:r>
+              <a:rPr lang="en-GB" dirty="0"/>
+              <a:t>      └ Database</a:t>
+            </a:r>
+          </a:p>
+          <a:p>
+            <a:pPr marL="0" indent="0">
+              <a:buNone/>
+            </a:pPr>
+            <a:r>
+              <a:rPr lang="en-GB" dirty="0"/>
+              <a:t>         └ Entities</a:t>
+            </a:r>
+          </a:p>
+          <a:p>
+            <a:r>
+              <a:rPr lang="en-GB" dirty="0"/>
+              <a:t>Entity Architecture</a:t>
+            </a:r>
+          </a:p>
+          <a:p>
+            <a:r>
+              <a:rPr lang="en-GB" dirty="0"/>
+              <a:t>AutoCAD Object Hierarchy</a:t>
+            </a:r>
+          </a:p>
+          <a:p>
+            <a:r>
+              <a:rPr lang="en-GB" dirty="0"/>
+              <a:t>Navigation through AutoCAD's core components</a:t>
+            </a:r>
+          </a:p>
+          <a:p>
+            <a:r>
+              <a:rPr lang="en-IN" dirty="0"/>
+              <a:t>Mini Project - Explore current drawing information.</a:t>
+            </a:r>
+          </a:p>
+        </p:txBody>
+      </p:sp>
+      <p:sp>
+        <p:nvSpPr>
+          <p:cNvPr id="5" name="Text Placeholder 4">
+            <a:extLst>
+              <a:ext uri="{FF2B5EF4-FFF2-40B4-BE49-F238E27FC236}">
+                <a16:creationId xmlns:a16="http://schemas.microsoft.com/office/drawing/2014/main" id="{576C69D4-4729-570E-8DA1-497CBC31D341}"/>
+              </a:ext>
+            </a:extLst>
+          </p:cNvPr>
+          <p:cNvSpPr>
+            <a:spLocks noGrp="1"/>
+          </p:cNvSpPr>
+          <p:nvPr>
+            <p:ph type="body" sz="quarter" idx="3"/>
+          </p:nvPr>
+        </p:nvSpPr>
+        <p:spPr/>
+        <p:txBody>
+          <a:bodyPr/>
+          <a:lstStyle/>
+          <a:p>
+            <a:r>
+              <a:rPr lang="en-IN" b="0" dirty="0"/>
+              <a:t>Outcome</a:t>
+            </a:r>
+          </a:p>
+        </p:txBody>
+      </p:sp>
+      <p:sp>
+        <p:nvSpPr>
+          <p:cNvPr id="6" name="Content Placeholder 5">
+            <a:extLst>
+              <a:ext uri="{FF2B5EF4-FFF2-40B4-BE49-F238E27FC236}">
+                <a16:creationId xmlns:a16="http://schemas.microsoft.com/office/drawing/2014/main" id="{C8AC1737-0AFC-C789-B4AE-56B1F8D6F39A}"/>
+              </a:ext>
+            </a:extLst>
+          </p:cNvPr>
+          <p:cNvSpPr>
+            <a:spLocks noGrp="1"/>
+          </p:cNvSpPr>
+          <p:nvPr>
+            <p:ph sz="quarter" idx="4"/>
+          </p:nvPr>
+        </p:nvSpPr>
+        <p:spPr/>
+        <p:txBody>
+          <a:bodyPr>
+            <a:normAutofit fontScale="85000" lnSpcReduction="20000"/>
+          </a:bodyPr>
+          <a:lstStyle/>
+          <a:p>
+            <a:r>
+              <a:rPr lang="en-IN" dirty="0"/>
+              <a:t>Understand AutoCAD object hierarchy.</a:t>
+            </a:r>
+          </a:p>
+        </p:txBody>
+      </p:sp>
+    </p:spTree>
+    <p:extLst>
+      <p:ext uri="{BB962C8B-B14F-4D97-AF65-F5344CB8AC3E}">
+        <p14:creationId xmlns:p14="http://schemas.microsoft.com/office/powerpoint/2010/main" val="3640761817"/>
+      </p:ext>
+    </p:extLst>
+  </p:cSld>
+  <p:clrMapOvr>
+    <a:masterClrMapping/>
+  </p:clrMapOvr>
+</p:sld>
+</file>
+
+<file path=ppt/slides/slide6.xml><?xml version="1.0" encoding="utf-8"?>
+<p:sld xmlns:a="http://schemas.openxmlformats.org/drawingml/2006/main" xmlns:r="http://schemas.openxmlformats.org/officeDocument/2006/relationships" xmlns:p="http://schemas.openxmlformats.org/presentationml/2006/main">
+  <p:cSld>
+    <p:spTree>
+      <p:nvGrpSpPr>
+        <p:cNvPr id="1" name="">
+          <a:extLst>
+            <a:ext uri="{FF2B5EF4-FFF2-40B4-BE49-F238E27FC236}">
               <a16:creationId xmlns:a16="http://schemas.microsoft.com/office/drawing/2014/main" id="{755527F8-4128-B598-D733-F4C4B83205E6}"/>
             </a:ext>
           </a:extLst>
@@ -5577,7 +6030,7 @@
 </p:sld>
 </file>
 
-<file path=ppt/slides/slide6.xml><?xml version="1.0" encoding="utf-8"?>
+<file path=ppt/slides/slide7.xml><?xml version="1.0" encoding="utf-8"?>
 <p:sld xmlns:a="http://schemas.openxmlformats.org/drawingml/2006/main" xmlns:r="http://schemas.openxmlformats.org/officeDocument/2006/relationships" xmlns:p="http://schemas.openxmlformats.org/presentationml/2006/main">
   <p:cSld>
     <p:spTree>
@@ -5684,7 +6137,7 @@
         <p:spPr/>
         <p:txBody>
           <a:bodyPr>
-            <a:normAutofit/>
+            <a:normAutofit fontScale="92500" lnSpcReduction="20000"/>
           </a:bodyPr>
           <a:lstStyle/>
           <a:p>
@@ -5710,8 +6163,25 @@
           <a:p>
             <a:r>
               <a:rPr lang="en-IN" dirty="0"/>
-              <a:t>Rollback</a:t>
-            </a:r>
+              <a:t>Rollback/ </a:t>
+            </a:r>
+            <a:r>
+              <a:rPr lang="en-GB" dirty="0"/>
+              <a:t>Abort</a:t>
+            </a:r>
+          </a:p>
+          <a:p>
+            <a:r>
+              <a:rPr lang="en-GB" dirty="0"/>
+              <a:t>Transaction Best Practices</a:t>
+            </a:r>
+          </a:p>
+          <a:p>
+            <a:r>
+              <a:rPr lang="en-GB" dirty="0"/>
+              <a:t>Safe Database Operations</a:t>
+            </a:r>
+            <a:endParaRPr lang="en-IN" dirty="0"/>
           </a:p>
           <a:p>
             <a:r>
@@ -5775,7 +6245,7 @@
         <p:spPr/>
         <p:txBody>
           <a:bodyPr>
-            <a:normAutofit/>
+            <a:normAutofit fontScale="92500" lnSpcReduction="20000"/>
           </a:bodyPr>
           <a:lstStyle/>
           <a:p>
@@ -5799,7 +6269,7 @@
 </p:sld>
 </file>
 
-<file path=ppt/slides/slide7.xml><?xml version="1.0" encoding="utf-8"?>
+<file path=ppt/slides/slide8.xml><?xml version="1.0" encoding="utf-8"?>
 <p:sld xmlns:a="http://schemas.openxmlformats.org/drawingml/2006/main" xmlns:r="http://schemas.openxmlformats.org/officeDocument/2006/relationships" xmlns:p="http://schemas.openxmlformats.org/presentationml/2006/main">
   <p:cSld>
     <p:spTree>
@@ -5906,32 +6376,51 @@
         <p:spPr/>
         <p:txBody>
           <a:bodyPr>
-            <a:normAutofit/>
+            <a:normAutofit fontScale="85000" lnSpcReduction="10000"/>
           </a:bodyPr>
           <a:lstStyle/>
           <a:p>
             <a:r>
-              <a:rPr lang="en-IN" dirty="0" err="1"/>
+              <a:rPr lang="en-GB" dirty="0" err="1"/>
               <a:t>LayerTable</a:t>
             </a:r>
-            <a:endParaRPr lang="en-IN" dirty="0"/>
-          </a:p>
-          <a:p>
-            <a:r>
-              <a:rPr lang="en-IN" dirty="0"/>
-              <a:t>Layer Creation</a:t>
-            </a:r>
-          </a:p>
-          <a:p>
-            <a:r>
-              <a:rPr lang="en-IN" dirty="0"/>
+            <a:endParaRPr lang="en-GB" dirty="0"/>
+          </a:p>
+          <a:p>
+            <a:r>
+              <a:rPr lang="en-GB" dirty="0" err="1"/>
+              <a:t>LayerTableRecord</a:t>
+            </a:r>
+            <a:endParaRPr lang="en-GB" dirty="0"/>
+          </a:p>
+          <a:p>
+            <a:r>
+              <a:rPr lang="en-GB" dirty="0"/>
+              <a:t>Creating Layers</a:t>
+            </a:r>
+          </a:p>
+          <a:p>
+            <a:r>
+              <a:rPr lang="en-GB" dirty="0"/>
+              <a:t>Checking Existing Layers</a:t>
+            </a:r>
+          </a:p>
+          <a:p>
+            <a:r>
+              <a:rPr lang="en-GB" dirty="0"/>
               <a:t>Layer Properties</a:t>
             </a:r>
           </a:p>
           <a:p>
             <a:r>
-              <a:rPr lang="en-IN" dirty="0"/>
-              <a:t>Layer Assignment</a:t>
+              <a:rPr lang="en-GB" dirty="0"/>
+              <a:t>Assigning Entities to Layers</a:t>
+            </a:r>
+          </a:p>
+          <a:p>
+            <a:r>
+              <a:rPr lang="en-GB" dirty="0"/>
+              <a:t>Layer Management Automation</a:t>
             </a:r>
           </a:p>
           <a:p>
@@ -5989,7 +6478,7 @@
         <p:spPr/>
         <p:txBody>
           <a:bodyPr>
-            <a:normAutofit/>
+            <a:normAutofit fontScale="85000" lnSpcReduction="10000"/>
           </a:bodyPr>
           <a:lstStyle/>
           <a:p>
@@ -6013,7 +6502,7 @@
 </p:sld>
 </file>
 
-<file path=ppt/slides/slide8.xml><?xml version="1.0" encoding="utf-8"?>
+<file path=ppt/slides/slide9.xml><?xml version="1.0" encoding="utf-8"?>
 <p:sld xmlns:a="http://schemas.openxmlformats.org/drawingml/2006/main" xmlns:r="http://schemas.openxmlformats.org/officeDocument/2006/relationships" xmlns:p="http://schemas.openxmlformats.org/presentationml/2006/main">
   <p:cSld>
     <p:spTree>
@@ -6213,213 +6702,6 @@
     <p:extLst>
       <p:ext uri="{BB962C8B-B14F-4D97-AF65-F5344CB8AC3E}">
         <p14:creationId xmlns:p14="http://schemas.microsoft.com/office/powerpoint/2010/main" val="3532443903"/>
-      </p:ext>
-    </p:extLst>
-  </p:cSld>
-  <p:clrMapOvr>
-    <a:masterClrMapping/>
-  </p:clrMapOvr>
-</p:sld>
-</file>
-
-<file path=ppt/slides/slide9.xml><?xml version="1.0" encoding="utf-8"?>
-<p:sld xmlns:a="http://schemas.openxmlformats.org/drawingml/2006/main" xmlns:r="http://schemas.openxmlformats.org/officeDocument/2006/relationships" xmlns:p="http://schemas.openxmlformats.org/presentationml/2006/main">
-  <p:cSld>
-    <p:spTree>
-      <p:nvGrpSpPr>
-        <p:cNvPr id="1" name="">
-          <a:extLst>
-            <a:ext uri="{FF2B5EF4-FFF2-40B4-BE49-F238E27FC236}">
-              <a16:creationId xmlns:a16="http://schemas.microsoft.com/office/drawing/2014/main" id="{6ADD35A9-8484-397D-6E7E-B5FEC50ED72F}"/>
-            </a:ext>
-          </a:extLst>
-        </p:cNvPr>
-        <p:cNvGrpSpPr/>
-        <p:nvPr/>
-      </p:nvGrpSpPr>
-      <p:grpSpPr>
-        <a:xfrm>
-          <a:off x="0" y="0"/>
-          <a:ext cx="0" cy="0"/>
-          <a:chOff x="0" y="0"/>
-          <a:chExt cx="0" cy="0"/>
-        </a:xfrm>
-      </p:grpSpPr>
-      <p:sp>
-        <p:nvSpPr>
-          <p:cNvPr id="2" name="Title 1">
-            <a:extLst>
-              <a:ext uri="{FF2B5EF4-FFF2-40B4-BE49-F238E27FC236}">
-                <a16:creationId xmlns:a16="http://schemas.microsoft.com/office/drawing/2014/main" id="{D7129BDA-D26A-B38D-776D-FDDF033B3E43}"/>
-              </a:ext>
-            </a:extLst>
-          </p:cNvPr>
-          <p:cNvSpPr>
-            <a:spLocks noGrp="1"/>
-          </p:cNvSpPr>
-          <p:nvPr>
-            <p:ph type="title"/>
-          </p:nvPr>
-        </p:nvSpPr>
-        <p:spPr/>
-        <p:txBody>
-          <a:bodyPr>
-            <a:normAutofit/>
-          </a:bodyPr>
-          <a:lstStyle/>
-          <a:p>
-            <a:r>
-              <a:rPr lang="en-IN" dirty="0"/>
-              <a:t>Chapter 9</a:t>
-            </a:r>
-            <a:br>
-              <a:rPr lang="en-IN" dirty="0"/>
-            </a:br>
-            <a:r>
-              <a:rPr lang="en-IN" dirty="0"/>
-              <a:t>Working with Polylines</a:t>
-            </a:r>
-          </a:p>
-        </p:txBody>
-      </p:sp>
-      <p:sp>
-        <p:nvSpPr>
-          <p:cNvPr id="3" name="Text Placeholder 2">
-            <a:extLst>
-              <a:ext uri="{FF2B5EF4-FFF2-40B4-BE49-F238E27FC236}">
-                <a16:creationId xmlns:a16="http://schemas.microsoft.com/office/drawing/2014/main" id="{855F551E-0F5F-1964-97E2-D658EA3D8D65}"/>
-              </a:ext>
-            </a:extLst>
-          </p:cNvPr>
-          <p:cNvSpPr>
-            <a:spLocks noGrp="1"/>
-          </p:cNvSpPr>
-          <p:nvPr>
-            <p:ph type="body" idx="1"/>
-          </p:nvPr>
-        </p:nvSpPr>
-        <p:spPr/>
-        <p:txBody>
-          <a:bodyPr/>
-          <a:lstStyle/>
-          <a:p>
-            <a:r>
-              <a:rPr lang="en-IN" b="0" dirty="0"/>
-              <a:t>Topics</a:t>
-            </a:r>
-          </a:p>
-        </p:txBody>
-      </p:sp>
-      <p:sp>
-        <p:nvSpPr>
-          <p:cNvPr id="4" name="Content Placeholder 3">
-            <a:extLst>
-              <a:ext uri="{FF2B5EF4-FFF2-40B4-BE49-F238E27FC236}">
-                <a16:creationId xmlns:a16="http://schemas.microsoft.com/office/drawing/2014/main" id="{C8E9BBB0-178C-BAFD-96F7-49D545C2684C}"/>
-              </a:ext>
-            </a:extLst>
-          </p:cNvPr>
-          <p:cNvSpPr>
-            <a:spLocks noGrp="1"/>
-          </p:cNvSpPr>
-          <p:nvPr>
-            <p:ph sz="half" idx="2"/>
-          </p:nvPr>
-        </p:nvSpPr>
-        <p:spPr/>
-        <p:txBody>
-          <a:bodyPr>
-            <a:normAutofit/>
-          </a:bodyPr>
-          <a:lstStyle/>
-          <a:p>
-            <a:r>
-              <a:rPr lang="en-IN" dirty="0"/>
-              <a:t>Polyline</a:t>
-            </a:r>
-          </a:p>
-          <a:p>
-            <a:r>
-              <a:rPr lang="en-IN" dirty="0"/>
-              <a:t>Vertex Management</a:t>
-            </a:r>
-          </a:p>
-          <a:p>
-            <a:r>
-              <a:rPr lang="en-IN" dirty="0"/>
-              <a:t>Closed Shapes</a:t>
-            </a:r>
-          </a:p>
-          <a:p>
-            <a:r>
-              <a:rPr lang="en-IN" dirty="0"/>
-              <a:t>Mini Project - Generate floor layouts.</a:t>
-            </a:r>
-          </a:p>
-        </p:txBody>
-      </p:sp>
-      <p:sp>
-        <p:nvSpPr>
-          <p:cNvPr id="5" name="Text Placeholder 4">
-            <a:extLst>
-              <a:ext uri="{FF2B5EF4-FFF2-40B4-BE49-F238E27FC236}">
-                <a16:creationId xmlns:a16="http://schemas.microsoft.com/office/drawing/2014/main" id="{3F1FE253-2395-591D-CA2B-414001105EFF}"/>
-              </a:ext>
-            </a:extLst>
-          </p:cNvPr>
-          <p:cNvSpPr>
-            <a:spLocks noGrp="1"/>
-          </p:cNvSpPr>
-          <p:nvPr>
-            <p:ph type="body" sz="quarter" idx="3"/>
-          </p:nvPr>
-        </p:nvSpPr>
-        <p:spPr/>
-        <p:txBody>
-          <a:bodyPr/>
-          <a:lstStyle/>
-          <a:p>
-            <a:r>
-              <a:rPr lang="en-IN" b="0" dirty="0"/>
-              <a:t>Outcome</a:t>
-            </a:r>
-          </a:p>
-        </p:txBody>
-      </p:sp>
-      <p:sp>
-        <p:nvSpPr>
-          <p:cNvPr id="6" name="Content Placeholder 5">
-            <a:extLst>
-              <a:ext uri="{FF2B5EF4-FFF2-40B4-BE49-F238E27FC236}">
-                <a16:creationId xmlns:a16="http://schemas.microsoft.com/office/drawing/2014/main" id="{8967E232-99D9-BA37-1119-72E34A7E87C8}"/>
-              </a:ext>
-            </a:extLst>
-          </p:cNvPr>
-          <p:cNvSpPr>
-            <a:spLocks noGrp="1"/>
-          </p:cNvSpPr>
-          <p:nvPr>
-            <p:ph sz="quarter" idx="4"/>
-          </p:nvPr>
-        </p:nvSpPr>
-        <p:spPr/>
-        <p:txBody>
-          <a:bodyPr>
-            <a:normAutofit/>
-          </a:bodyPr>
-          <a:lstStyle/>
-          <a:p>
-            <a:r>
-              <a:rPr lang="en-IN" dirty="0"/>
-              <a:t>Complex geometry creation.</a:t>
-            </a:r>
-          </a:p>
-        </p:txBody>
-      </p:sp>
-    </p:spTree>
-    <p:extLst>
-      <p:ext uri="{BB962C8B-B14F-4D97-AF65-F5344CB8AC3E}">
-        <p14:creationId xmlns:p14="http://schemas.microsoft.com/office/powerpoint/2010/main" val="1726483327"/>
       </p:ext>
     </p:extLst>
   </p:cSld>
@@ -6722,4 +7004,10 @@
     </a:ext>
   </a:extLst>
 </a:theme>
+</file>
+
+<file path=docMetadata/LabelInfo.xml><?xml version="1.0" encoding="utf-8"?>
+<clbl:labelList xmlns:clbl="http://schemas.microsoft.com/office/2020/mipLabelMetadata">
+  <clbl:label id="{dcf2f2b0-237a-4418-9927-9eefd42ac953}" enabled="1" method="Standard" siteId="{47312dc6-0a91-4272-a8a5-031fca130189}" contentBits="0" removed="0"/>
+</clbl:labelList>
 </file>
</xml_diff>